<commit_message>
Deck: fill team name and leader
Co-Authored-By: Claude Fable 5.1 <noreply@anthropic.com>
</commit_message>
<xml_diff>
--- a/docs/FactoryPulse_Submission_Deck.pptx
+++ b/docs/FactoryPulse_Submission_Deck.pptx
@@ -9162,7 +9162,7 @@
                 <a:cs typeface="Manrope SemiBold"/>
                 <a:sym typeface="Manrope SemiBold"/>
               </a:rPr>
-              <a:t>&lt;Team name&gt;</a:t>
+              <a:t>ICE</a:t>
             </a:r>
             <a:endParaRPr b="0" i="0" sz="1343" u="none" cap="none" strike="noStrike">
               <a:solidFill>
@@ -9318,7 +9318,7 @@
                 <a:cs typeface="Manrope SemiBold"/>
                 <a:sym typeface="Manrope SemiBold"/>
               </a:rPr>
-              <a:t>&lt;Team leader name&gt;</a:t>
+              <a:t>Amogh Kotha Nagaraj</a:t>
             </a:r>
             <a:endParaRPr b="0" i="0" sz="1343" u="none" cap="none" strike="noStrike">
               <a:solidFill>

</xml_diff>